<commit_message>
Slide 6: Ricardo above strategic heads, Marcomm reports directly to Ricardo
Co-Authored-By: Claude Opus 5.5 <noreply@anthropic.com>
Claude-Session: https://claude.ai/code/session_01Cx9kswyecF7JAB1Rr5vVcV
</commit_message>
<xml_diff>
--- a/nedp_deck/v4/Slide06_Organization.pptx
+++ b/nedp_deck/v4/Slide06_Organization.pptx
@@ -3593,8 +3593,8 @@
         </p:nvCxnSpPr>
         <p:spPr>
           <a:xfrm>
-            <a:off x="1581150" y="2438400"/>
-            <a:ext cx="9029700" cy="0"/>
+            <a:off x="7143750" y="2095500"/>
+            <a:ext cx="1238250" cy="0"/>
           </a:xfrm>
           <a:prstGeom prst="line">
             <a:avLst/>
@@ -3606,186 +3606,20 @@
           </a:ln>
         </p:spPr>
       </p:cxnSp>
-      <p:cxnSp>
-        <p:nvCxnSpPr>
-          <p:cNvPr id="19" name="Connector 18"/>
-          <p:cNvCxnSpPr/>
-          <p:nvPr/>
-        </p:nvCxnSpPr>
-        <p:spPr>
-          <a:xfrm>
-            <a:off x="1581150" y="2438400"/>
-            <a:ext cx="0" cy="152400"/>
-          </a:xfrm>
-          <a:prstGeom prst="line">
-            <a:avLst/>
-          </a:prstGeom>
-          <a:ln w="19050">
-            <a:solidFill>
-              <a:srgbClr val="4D555C"/>
-            </a:solidFill>
-          </a:ln>
-        </p:spPr>
-      </p:cxnSp>
-      <p:sp>
-        <p:nvSpPr>
-          <p:cNvPr id="20" name="Rounded Rectangle 19"/>
+      <p:sp>
+        <p:nvSpPr>
+          <p:cNvPr id="19" name="Rounded Rectangle 18"/>
           <p:cNvSpPr/>
           <p:nvPr/>
         </p:nvSpPr>
         <p:spPr>
           <a:xfrm>
-            <a:off x="533400" y="2590800"/>
-            <a:ext cx="2095500" cy="400050"/>
+            <a:off x="8382000" y="1866900"/>
+            <a:ext cx="3276600" cy="457200"/>
           </a:xfrm>
           <a:prstGeom prst="roundRect">
             <a:avLst>
-              <a:gd name="adj" fmla="val 11904"/>
-            </a:avLst>
-          </a:prstGeom>
-          <a:solidFill>
-            <a:srgbClr val="11181C"/>
-          </a:solidFill>
-          <a:ln>
-            <a:noFill/>
-          </a:ln>
-        </p:spPr>
-        <p:txBody>
-          <a:bodyPr rtlCol="0" anchor="ctr"/>
-          <a:lstStyle/>
-          <a:p/>
-        </p:txBody>
-      </p:sp>
-      <p:sp>
-        <p:nvSpPr>
-          <p:cNvPr id="21" name="TextBox 20"/>
-          <p:cNvSpPr txBox="1"/>
-          <p:nvPr/>
-        </p:nvSpPr>
-        <p:spPr>
-          <a:xfrm>
-            <a:off x="590550" y="2638425"/>
-            <a:ext cx="1981200" cy="152400"/>
-          </a:xfrm>
-          <a:prstGeom prst="rect">
-            <a:avLst/>
-          </a:prstGeom>
-          <a:noFill/>
-        </p:spPr>
-        <p:txBody>
-          <a:bodyPr wrap="square" lIns="0" rIns="0" tIns="0" bIns="0" anchor="t">
-            <a:spAutoFit/>
-          </a:bodyPr>
-          <a:lstStyle/>
-          <a:p>
-            <a:pPr algn="ctr"/>
-            <a:r>
-              <a:rPr sz="1000" b="1" i="0">
-                <a:solidFill>
-                  <a:srgbClr val="FFFFFF"/>
-                </a:solidFill>
-                <a:latin typeface="Arial"/>
-              </a:rPr>
-              <a:t>Kresnanto A.W.</a:t>
-            </a:r>
-          </a:p>
-        </p:txBody>
-      </p:sp>
-      <p:sp>
-        <p:nvSpPr>
-          <p:cNvPr id="22" name="TextBox 21"/>
-          <p:cNvSpPr txBox="1"/>
-          <p:nvPr/>
-        </p:nvSpPr>
-        <p:spPr>
-          <a:xfrm>
-            <a:off x="590550" y="2790825"/>
-            <a:ext cx="1981200" cy="190500"/>
-          </a:xfrm>
-          <a:prstGeom prst="rect">
-            <a:avLst/>
-          </a:prstGeom>
-          <a:noFill/>
-        </p:spPr>
-        <p:txBody>
-          <a:bodyPr wrap="square" lIns="0" rIns="0" tIns="0" bIns="0" anchor="t">
-            <a:spAutoFit/>
-          </a:bodyPr>
-          <a:lstStyle/>
-          <a:p>
-            <a:pPr algn="ctr">
-              <a:lnSpc>
-                <a:spcPct val="100000"/>
-              </a:lnSpc>
-            </a:pPr>
-            <a:r>
-              <a:rPr sz="750" b="1" i="0">
-                <a:solidFill>
-                  <a:srgbClr val="83E7AE"/>
-                </a:solidFill>
-                <a:latin typeface="Arial"/>
-              </a:rPr>
-              <a:t>MKT STRATEGIC 1 HEAD</a:t>
-            </a:r>
-          </a:p>
-        </p:txBody>
-      </p:sp>
-      <p:cxnSp>
-        <p:nvCxnSpPr>
-          <p:cNvPr id="23" name="Connector 22"/>
-          <p:cNvCxnSpPr/>
-          <p:nvPr/>
-        </p:nvCxnSpPr>
-        <p:spPr>
-          <a:xfrm>
-            <a:off x="628650" y="2990850"/>
-            <a:ext cx="0" cy="866775"/>
-          </a:xfrm>
-          <a:prstGeom prst="line">
-            <a:avLst/>
-          </a:prstGeom>
-          <a:ln w="19050">
-            <a:solidFill>
-              <a:srgbClr val="4D555C"/>
-            </a:solidFill>
-          </a:ln>
-        </p:spPr>
-      </p:cxnSp>
-      <p:cxnSp>
-        <p:nvCxnSpPr>
-          <p:cNvPr id="24" name="Connector 23"/>
-          <p:cNvCxnSpPr/>
-          <p:nvPr/>
-        </p:nvCxnSpPr>
-        <p:spPr>
-          <a:xfrm>
-            <a:off x="628650" y="3324225"/>
-            <a:ext cx="76200" cy="0"/>
-          </a:xfrm>
-          <a:prstGeom prst="line">
-            <a:avLst/>
-          </a:prstGeom>
-          <a:ln w="19050">
-            <a:solidFill>
-              <a:srgbClr val="4D555C"/>
-            </a:solidFill>
-          </a:ln>
-        </p:spPr>
-      </p:cxnSp>
-      <p:sp>
-        <p:nvSpPr>
-          <p:cNvPr id="25" name="Rounded Rectangle 24"/>
-          <p:cNvSpPr/>
-          <p:nvPr/>
-        </p:nvSpPr>
-        <p:spPr>
-          <a:xfrm>
-            <a:off x="704850" y="3086100"/>
-            <a:ext cx="1924050" cy="476250"/>
-          </a:xfrm>
-          <a:prstGeom prst="roundRect">
-            <a:avLst>
-              <a:gd name="adj" fmla="val 10000"/>
+              <a:gd name="adj" fmla="val 10416"/>
             </a:avLst>
           </a:prstGeom>
           <a:solidFill>
@@ -3805,14 +3639,14 @@
       </p:sp>
       <p:sp>
         <p:nvSpPr>
-          <p:cNvPr id="26" name="TextBox 25"/>
+          <p:cNvPr id="20" name="TextBox 19"/>
           <p:cNvSpPr txBox="1"/>
           <p:nvPr/>
         </p:nvSpPr>
         <p:spPr>
           <a:xfrm>
-            <a:off x="762000" y="3133725"/>
-            <a:ext cx="1809750" cy="152400"/>
+            <a:off x="8439150" y="1914525"/>
+            <a:ext cx="3162300" cy="152400"/>
           </a:xfrm>
           <a:prstGeom prst="rect">
             <a:avLst/>
@@ -3833,21 +3667,21 @@
                 </a:solidFill>
                 <a:latin typeface="Arial"/>
               </a:rPr>
-              <a:t>Satrio F.R.</a:t>
-            </a:r>
-          </a:p>
-        </p:txBody>
-      </p:sp>
-      <p:sp>
-        <p:nvSpPr>
-          <p:cNvPr id="27" name="TextBox 26"/>
+              <a:t>Marketing Communication</a:t>
+            </a:r>
+          </a:p>
+        </p:txBody>
+      </p:sp>
+      <p:sp>
+        <p:nvSpPr>
+          <p:cNvPr id="21" name="TextBox 20"/>
           <p:cNvSpPr txBox="1"/>
           <p:nvPr/>
         </p:nvSpPr>
         <p:spPr>
           <a:xfrm>
-            <a:off x="762000" y="3286125"/>
-            <a:ext cx="1809750" cy="266700"/>
+            <a:off x="8439150" y="2066925"/>
+            <a:ext cx="3162300" cy="247650"/>
           </a:xfrm>
           <a:prstGeom prst="rect">
             <a:avLst/>
@@ -3872,21 +3706,21 @@
                 </a:solidFill>
                 <a:latin typeface="Arial"/>
               </a:rPr>
-              <a:t>Big Suppeq, Big Vessel, Bucket</a:t>
+              <a:t>Karina Audina E. · Adinda Siti K. (Marcomm) · Rahma (Graphic Designer)</a:t>
             </a:r>
           </a:p>
         </p:txBody>
       </p:sp>
       <p:cxnSp>
         <p:nvCxnSpPr>
-          <p:cNvPr id="28" name="Connector 27"/>
+          <p:cNvPr id="22" name="Connector 21"/>
           <p:cNvCxnSpPr/>
           <p:nvPr/>
         </p:nvCxnSpPr>
         <p:spPr>
           <a:xfrm>
-            <a:off x="628650" y="3857625"/>
-            <a:ext cx="76200" cy="0"/>
+            <a:off x="1800225" y="2438400"/>
+            <a:ext cx="8591550" cy="0"/>
           </a:xfrm>
           <a:prstGeom prst="line">
             <a:avLst/>
@@ -3898,6 +3732,172 @@
           </a:ln>
         </p:spPr>
       </p:cxnSp>
+      <p:cxnSp>
+        <p:nvCxnSpPr>
+          <p:cNvPr id="23" name="Connector 22"/>
+          <p:cNvCxnSpPr/>
+          <p:nvPr/>
+        </p:nvCxnSpPr>
+        <p:spPr>
+          <a:xfrm>
+            <a:off x="1800225" y="2438400"/>
+            <a:ext cx="0" cy="152400"/>
+          </a:xfrm>
+          <a:prstGeom prst="line">
+            <a:avLst/>
+          </a:prstGeom>
+          <a:ln w="19050">
+            <a:solidFill>
+              <a:srgbClr val="4D555C"/>
+            </a:solidFill>
+          </a:ln>
+        </p:spPr>
+      </p:cxnSp>
+      <p:sp>
+        <p:nvSpPr>
+          <p:cNvPr id="24" name="Rounded Rectangle 23"/>
+          <p:cNvSpPr/>
+          <p:nvPr/>
+        </p:nvSpPr>
+        <p:spPr>
+          <a:xfrm>
+            <a:off x="533400" y="2590800"/>
+            <a:ext cx="2533650" cy="419100"/>
+          </a:xfrm>
+          <a:prstGeom prst="roundRect">
+            <a:avLst>
+              <a:gd name="adj" fmla="val 11363"/>
+            </a:avLst>
+          </a:prstGeom>
+          <a:solidFill>
+            <a:srgbClr val="11181C"/>
+          </a:solidFill>
+          <a:ln>
+            <a:noFill/>
+          </a:ln>
+        </p:spPr>
+        <p:txBody>
+          <a:bodyPr rtlCol="0" anchor="ctr"/>
+          <a:lstStyle/>
+          <a:p/>
+        </p:txBody>
+      </p:sp>
+      <p:sp>
+        <p:nvSpPr>
+          <p:cNvPr id="25" name="TextBox 24"/>
+          <p:cNvSpPr txBox="1"/>
+          <p:nvPr/>
+        </p:nvSpPr>
+        <p:spPr>
+          <a:xfrm>
+            <a:off x="590550" y="2638425"/>
+            <a:ext cx="2419350" cy="152400"/>
+          </a:xfrm>
+          <a:prstGeom prst="rect">
+            <a:avLst/>
+          </a:prstGeom>
+          <a:noFill/>
+        </p:spPr>
+        <p:txBody>
+          <a:bodyPr wrap="square" lIns="0" rIns="0" tIns="0" bIns="0" anchor="t">
+            <a:spAutoFit/>
+          </a:bodyPr>
+          <a:lstStyle/>
+          <a:p>
+            <a:pPr algn="ctr"/>
+            <a:r>
+              <a:rPr sz="1000" b="1" i="0">
+                <a:solidFill>
+                  <a:srgbClr val="FFFFFF"/>
+                </a:solidFill>
+                <a:latin typeface="Arial"/>
+              </a:rPr>
+              <a:t>Kresnanto A.W.</a:t>
+            </a:r>
+          </a:p>
+        </p:txBody>
+      </p:sp>
+      <p:sp>
+        <p:nvSpPr>
+          <p:cNvPr id="26" name="TextBox 25"/>
+          <p:cNvSpPr txBox="1"/>
+          <p:nvPr/>
+        </p:nvSpPr>
+        <p:spPr>
+          <a:xfrm>
+            <a:off x="590550" y="2790825"/>
+            <a:ext cx="2419350" cy="209550"/>
+          </a:xfrm>
+          <a:prstGeom prst="rect">
+            <a:avLst/>
+          </a:prstGeom>
+          <a:noFill/>
+        </p:spPr>
+        <p:txBody>
+          <a:bodyPr wrap="square" lIns="0" rIns="0" tIns="0" bIns="0" anchor="t">
+            <a:spAutoFit/>
+          </a:bodyPr>
+          <a:lstStyle/>
+          <a:p>
+            <a:pPr algn="ctr">
+              <a:lnSpc>
+                <a:spcPct val="100000"/>
+              </a:lnSpc>
+            </a:pPr>
+            <a:r>
+              <a:rPr sz="750" b="1" i="0">
+                <a:solidFill>
+                  <a:srgbClr val="83E7AE"/>
+                </a:solidFill>
+                <a:latin typeface="Arial"/>
+              </a:rPr>
+              <a:t>MKT STRATEGIC 1 HEAD</a:t>
+            </a:r>
+          </a:p>
+        </p:txBody>
+      </p:sp>
+      <p:cxnSp>
+        <p:nvCxnSpPr>
+          <p:cNvPr id="27" name="Connector 26"/>
+          <p:cNvCxnSpPr/>
+          <p:nvPr/>
+        </p:nvCxnSpPr>
+        <p:spPr>
+          <a:xfrm>
+            <a:off x="628650" y="3009900"/>
+            <a:ext cx="0" cy="857250"/>
+          </a:xfrm>
+          <a:prstGeom prst="line">
+            <a:avLst/>
+          </a:prstGeom>
+          <a:ln w="19050">
+            <a:solidFill>
+              <a:srgbClr val="4D555C"/>
+            </a:solidFill>
+          </a:ln>
+        </p:spPr>
+      </p:cxnSp>
+      <p:cxnSp>
+        <p:nvCxnSpPr>
+          <p:cNvPr id="28" name="Connector 27"/>
+          <p:cNvCxnSpPr/>
+          <p:nvPr/>
+        </p:nvCxnSpPr>
+        <p:spPr>
+          <a:xfrm>
+            <a:off x="628650" y="3333750"/>
+            <a:ext cx="76200" cy="0"/>
+          </a:xfrm>
+          <a:prstGeom prst="line">
+            <a:avLst/>
+          </a:prstGeom>
+          <a:ln w="19050">
+            <a:solidFill>
+              <a:srgbClr val="4D555C"/>
+            </a:solidFill>
+          </a:ln>
+        </p:spPr>
+      </p:cxnSp>
       <p:sp>
         <p:nvSpPr>
           <p:cNvPr id="29" name="Rounded Rectangle 28"/>
@@ -3906,12 +3906,12 @@
         </p:nvSpPr>
         <p:spPr>
           <a:xfrm>
-            <a:off x="704850" y="3619500"/>
-            <a:ext cx="1924050" cy="476250"/>
+            <a:off x="704850" y="3105150"/>
+            <a:ext cx="2362200" cy="457200"/>
           </a:xfrm>
           <a:prstGeom prst="roundRect">
             <a:avLst>
-              <a:gd name="adj" fmla="val 10000"/>
+              <a:gd name="adj" fmla="val 10416"/>
             </a:avLst>
           </a:prstGeom>
           <a:solidFill>
@@ -3937,8 +3937,8 @@
         </p:nvSpPr>
         <p:spPr>
           <a:xfrm>
-            <a:off x="762000" y="3667125"/>
-            <a:ext cx="1809750" cy="152400"/>
+            <a:off x="762000" y="3152775"/>
+            <a:ext cx="2247900" cy="152400"/>
           </a:xfrm>
           <a:prstGeom prst="rect">
             <a:avLst/>
@@ -3959,7 +3959,7 @@
                 </a:solidFill>
                 <a:latin typeface="Arial"/>
               </a:rPr>
-              <a:t>M. Fawwaz J.</a:t>
+              <a:t>Satrio F.R.</a:t>
             </a:r>
           </a:p>
         </p:txBody>
@@ -3972,8 +3972,8 @@
         </p:nvSpPr>
         <p:spPr>
           <a:xfrm>
-            <a:off x="762000" y="3819525"/>
-            <a:ext cx="1809750" cy="266700"/>
+            <a:off x="762000" y="3305175"/>
+            <a:ext cx="2247900" cy="247650"/>
           </a:xfrm>
           <a:prstGeom prst="rect">
             <a:avLst/>
@@ -3998,7 +3998,7 @@
                 </a:solidFill>
                 <a:latin typeface="Arial"/>
               </a:rPr>
-              <a:t>Cabin, Forestry, Agro, Forklift, Towerlamp, Pump</a:t>
+              <a:t>Big Suppeq, Big Vessel, Bucket</a:t>
             </a:r>
           </a:p>
         </p:txBody>
@@ -4011,8 +4011,8 @@
         </p:nvCxnSpPr>
         <p:spPr>
           <a:xfrm>
-            <a:off x="3838575" y="2438400"/>
-            <a:ext cx="0" cy="152400"/>
+            <a:off x="628650" y="3867150"/>
+            <a:ext cx="76200" cy="0"/>
           </a:xfrm>
           <a:prstGeom prst="line">
             <a:avLst/>
@@ -4032,186 +4032,12 @@
         </p:nvSpPr>
         <p:spPr>
           <a:xfrm>
-            <a:off x="2733675" y="2533650"/>
-            <a:ext cx="2209800" cy="3543300"/>
+            <a:off x="704850" y="3638550"/>
+            <a:ext cx="2362200" cy="457200"/>
           </a:xfrm>
           <a:prstGeom prst="roundRect">
             <a:avLst>
-              <a:gd name="adj" fmla="val 3448"/>
-            </a:avLst>
-          </a:prstGeom>
-          <a:noFill/>
-          <a:ln w="19050">
-            <a:solidFill>
-              <a:srgbClr val="076932"/>
-            </a:solidFill>
-          </a:ln>
-        </p:spPr>
-        <p:txBody>
-          <a:bodyPr rtlCol="0" anchor="ctr"/>
-          <a:lstStyle/>
-          <a:p/>
-        </p:txBody>
-      </p:sp>
-      <p:sp>
-        <p:nvSpPr>
-          <p:cNvPr id="34" name="Rounded Rectangle 33"/>
-          <p:cNvSpPr/>
-          <p:nvPr/>
-        </p:nvSpPr>
-        <p:spPr>
-          <a:xfrm>
-            <a:off x="2790825" y="2590800"/>
-            <a:ext cx="2095500" cy="400050"/>
-          </a:xfrm>
-          <a:prstGeom prst="roundRect">
-            <a:avLst>
-              <a:gd name="adj" fmla="val 11904"/>
-            </a:avLst>
-          </a:prstGeom>
-          <a:solidFill>
-            <a:srgbClr val="11181C"/>
-          </a:solidFill>
-          <a:ln>
-            <a:noFill/>
-          </a:ln>
-        </p:spPr>
-        <p:txBody>
-          <a:bodyPr rtlCol="0" anchor="ctr"/>
-          <a:lstStyle/>
-          <a:p/>
-        </p:txBody>
-      </p:sp>
-      <p:sp>
-        <p:nvSpPr>
-          <p:cNvPr id="35" name="TextBox 34"/>
-          <p:cNvSpPr txBox="1"/>
-          <p:nvPr/>
-        </p:nvSpPr>
-        <p:spPr>
-          <a:xfrm>
-            <a:off x="2847975" y="2638425"/>
-            <a:ext cx="1981200" cy="152400"/>
-          </a:xfrm>
-          <a:prstGeom prst="rect">
-            <a:avLst/>
-          </a:prstGeom>
-          <a:noFill/>
-        </p:spPr>
-        <p:txBody>
-          <a:bodyPr wrap="square" lIns="0" rIns="0" tIns="0" bIns="0" anchor="t">
-            <a:spAutoFit/>
-          </a:bodyPr>
-          <a:lstStyle/>
-          <a:p>
-            <a:pPr algn="ctr"/>
-            <a:r>
-              <a:rPr sz="1000" b="1" i="0">
-                <a:solidFill>
-                  <a:srgbClr val="FFFFFF"/>
-                </a:solidFill>
-                <a:latin typeface="Arial"/>
-              </a:rPr>
-              <a:t>Ricardo Tanada (c)</a:t>
-            </a:r>
-          </a:p>
-        </p:txBody>
-      </p:sp>
-      <p:sp>
-        <p:nvSpPr>
-          <p:cNvPr id="36" name="TextBox 35"/>
-          <p:cNvSpPr txBox="1"/>
-          <p:nvPr/>
-        </p:nvSpPr>
-        <p:spPr>
-          <a:xfrm>
-            <a:off x="2847975" y="2790825"/>
-            <a:ext cx="1981200" cy="190500"/>
-          </a:xfrm>
-          <a:prstGeom prst="rect">
-            <a:avLst/>
-          </a:prstGeom>
-          <a:noFill/>
-        </p:spPr>
-        <p:txBody>
-          <a:bodyPr wrap="square" lIns="0" rIns="0" tIns="0" bIns="0" anchor="t">
-            <a:spAutoFit/>
-          </a:bodyPr>
-          <a:lstStyle/>
-          <a:p>
-            <a:pPr algn="ctr">
-              <a:lnSpc>
-                <a:spcPct val="100000"/>
-              </a:lnSpc>
-            </a:pPr>
-            <a:r>
-              <a:rPr sz="750" b="1" i="0">
-                <a:solidFill>
-                  <a:srgbClr val="83E7AE"/>
-                </a:solidFill>
-                <a:latin typeface="Arial"/>
-              </a:rPr>
-              <a:t>MKT STRATEGIC 2 HEAD</a:t>
-            </a:r>
-          </a:p>
-        </p:txBody>
-      </p:sp>
-      <p:cxnSp>
-        <p:nvCxnSpPr>
-          <p:cNvPr id="37" name="Connector 36"/>
-          <p:cNvCxnSpPr/>
-          <p:nvPr/>
-        </p:nvCxnSpPr>
-        <p:spPr>
-          <a:xfrm>
-            <a:off x="2886075" y="2990850"/>
-            <a:ext cx="0" cy="2790825"/>
-          </a:xfrm>
-          <a:prstGeom prst="line">
-            <a:avLst/>
-          </a:prstGeom>
-          <a:ln w="19050">
-            <a:solidFill>
-              <a:srgbClr val="4D555C"/>
-            </a:solidFill>
-          </a:ln>
-        </p:spPr>
-      </p:cxnSp>
-      <p:cxnSp>
-        <p:nvCxnSpPr>
-          <p:cNvPr id="38" name="Connector 37"/>
-          <p:cNvCxnSpPr/>
-          <p:nvPr/>
-        </p:nvCxnSpPr>
-        <p:spPr>
-          <a:xfrm>
-            <a:off x="2886075" y="3305175"/>
-            <a:ext cx="76200" cy="0"/>
-          </a:xfrm>
-          <a:prstGeom prst="line">
-            <a:avLst/>
-          </a:prstGeom>
-          <a:ln w="19050">
-            <a:solidFill>
-              <a:srgbClr val="4D555C"/>
-            </a:solidFill>
-          </a:ln>
-        </p:spPr>
-      </p:cxnSp>
-      <p:sp>
-        <p:nvSpPr>
-          <p:cNvPr id="39" name="Rounded Rectangle 38"/>
-          <p:cNvSpPr/>
-          <p:nvPr/>
-        </p:nvSpPr>
-        <p:spPr>
-          <a:xfrm>
-            <a:off x="2962275" y="3086100"/>
-            <a:ext cx="1924050" cy="438150"/>
-          </a:xfrm>
-          <a:prstGeom prst="roundRect">
-            <a:avLst>
-              <a:gd name="adj" fmla="val 10869"/>
+              <a:gd name="adj" fmla="val 10416"/>
             </a:avLst>
           </a:prstGeom>
           <a:solidFill>
@@ -4231,14 +4057,14 @@
       </p:sp>
       <p:sp>
         <p:nvSpPr>
-          <p:cNvPr id="40" name="TextBox 39"/>
+          <p:cNvPr id="34" name="TextBox 33"/>
           <p:cNvSpPr txBox="1"/>
           <p:nvPr/>
         </p:nvSpPr>
         <p:spPr>
           <a:xfrm>
-            <a:off x="3019425" y="3133725"/>
-            <a:ext cx="1809750" cy="152400"/>
+            <a:off x="762000" y="3686175"/>
+            <a:ext cx="2247900" cy="152400"/>
           </a:xfrm>
           <a:prstGeom prst="rect">
             <a:avLst/>
@@ -4259,21 +4085,21 @@
                 </a:solidFill>
                 <a:latin typeface="Arial"/>
               </a:rPr>
-              <a:t>Ignatius Indrawan S.</a:t>
-            </a:r>
-          </a:p>
-        </p:txBody>
-      </p:sp>
-      <p:sp>
-        <p:nvSpPr>
-          <p:cNvPr id="41" name="TextBox 40"/>
+              <a:t>M. Fawwaz J.</a:t>
+            </a:r>
+          </a:p>
+        </p:txBody>
+      </p:sp>
+      <p:sp>
+        <p:nvSpPr>
+          <p:cNvPr id="35" name="TextBox 34"/>
           <p:cNvSpPr txBox="1"/>
           <p:nvPr/>
         </p:nvSpPr>
         <p:spPr>
           <a:xfrm>
-            <a:off x="3019425" y="3286125"/>
-            <a:ext cx="1809750" cy="228600"/>
+            <a:off x="762000" y="3838575"/>
+            <a:ext cx="2247900" cy="247650"/>
           </a:xfrm>
           <a:prstGeom prst="rect">
             <a:avLst/>
@@ -4298,21 +4124,21 @@
                 </a:solidFill>
                 <a:latin typeface="Arial"/>
               </a:rPr>
-              <a:t>Deputy Head</a:t>
+              <a:t>Cabin, Forestry, Agro, Forklift, Towerlamp, Pump</a:t>
             </a:r>
           </a:p>
         </p:txBody>
       </p:sp>
       <p:cxnSp>
         <p:nvCxnSpPr>
-          <p:cNvPr id="42" name="Connector 41"/>
+          <p:cNvPr id="36" name="Connector 35"/>
           <p:cNvCxnSpPr/>
           <p:nvPr/>
         </p:nvCxnSpPr>
         <p:spPr>
           <a:xfrm>
-            <a:off x="2886075" y="3800475"/>
-            <a:ext cx="76200" cy="0"/>
+            <a:off x="4664075" y="2438400"/>
+            <a:ext cx="0" cy="152400"/>
           </a:xfrm>
           <a:prstGeom prst="line">
             <a:avLst/>
@@ -4326,18 +4152,192 @@
       </p:cxnSp>
       <p:sp>
         <p:nvSpPr>
+          <p:cNvPr id="37" name="Rounded Rectangle 36"/>
+          <p:cNvSpPr/>
+          <p:nvPr/>
+        </p:nvSpPr>
+        <p:spPr>
+          <a:xfrm>
+            <a:off x="3340100" y="2533650"/>
+            <a:ext cx="2647950" cy="3257550"/>
+          </a:xfrm>
+          <a:prstGeom prst="roundRect">
+            <a:avLst>
+              <a:gd name="adj" fmla="val 2877"/>
+            </a:avLst>
+          </a:prstGeom>
+          <a:noFill/>
+          <a:ln w="19050">
+            <a:solidFill>
+              <a:srgbClr val="076932"/>
+            </a:solidFill>
+          </a:ln>
+        </p:spPr>
+        <p:txBody>
+          <a:bodyPr rtlCol="0" anchor="ctr"/>
+          <a:lstStyle/>
+          <a:p/>
+        </p:txBody>
+      </p:sp>
+      <p:sp>
+        <p:nvSpPr>
+          <p:cNvPr id="38" name="Rounded Rectangle 37"/>
+          <p:cNvSpPr/>
+          <p:nvPr/>
+        </p:nvSpPr>
+        <p:spPr>
+          <a:xfrm>
+            <a:off x="3397250" y="2590800"/>
+            <a:ext cx="2533650" cy="419100"/>
+          </a:xfrm>
+          <a:prstGeom prst="roundRect">
+            <a:avLst>
+              <a:gd name="adj" fmla="val 11363"/>
+            </a:avLst>
+          </a:prstGeom>
+          <a:solidFill>
+            <a:srgbClr val="11181C"/>
+          </a:solidFill>
+          <a:ln>
+            <a:noFill/>
+          </a:ln>
+        </p:spPr>
+        <p:txBody>
+          <a:bodyPr rtlCol="0" anchor="ctr"/>
+          <a:lstStyle/>
+          <a:p/>
+        </p:txBody>
+      </p:sp>
+      <p:sp>
+        <p:nvSpPr>
+          <p:cNvPr id="39" name="TextBox 38"/>
+          <p:cNvSpPr txBox="1"/>
+          <p:nvPr/>
+        </p:nvSpPr>
+        <p:spPr>
+          <a:xfrm>
+            <a:off x="3454400" y="2638425"/>
+            <a:ext cx="2419350" cy="152400"/>
+          </a:xfrm>
+          <a:prstGeom prst="rect">
+            <a:avLst/>
+          </a:prstGeom>
+          <a:noFill/>
+        </p:spPr>
+        <p:txBody>
+          <a:bodyPr wrap="square" lIns="0" rIns="0" tIns="0" bIns="0" anchor="t">
+            <a:spAutoFit/>
+          </a:bodyPr>
+          <a:lstStyle/>
+          <a:p>
+            <a:pPr algn="ctr"/>
+            <a:r>
+              <a:rPr sz="1000" b="1" i="0">
+                <a:solidFill>
+                  <a:srgbClr val="FFFFFF"/>
+                </a:solidFill>
+                <a:latin typeface="Arial"/>
+              </a:rPr>
+              <a:t>Ignatius Indrawan S.</a:t>
+            </a:r>
+          </a:p>
+        </p:txBody>
+      </p:sp>
+      <p:sp>
+        <p:nvSpPr>
+          <p:cNvPr id="40" name="TextBox 39"/>
+          <p:cNvSpPr txBox="1"/>
+          <p:nvPr/>
+        </p:nvSpPr>
+        <p:spPr>
+          <a:xfrm>
+            <a:off x="3454400" y="2790825"/>
+            <a:ext cx="2419350" cy="209550"/>
+          </a:xfrm>
+          <a:prstGeom prst="rect">
+            <a:avLst/>
+          </a:prstGeom>
+          <a:noFill/>
+        </p:spPr>
+        <p:txBody>
+          <a:bodyPr wrap="square" lIns="0" rIns="0" tIns="0" bIns="0" anchor="t">
+            <a:spAutoFit/>
+          </a:bodyPr>
+          <a:lstStyle/>
+          <a:p>
+            <a:pPr algn="ctr">
+              <a:lnSpc>
+                <a:spcPct val="100000"/>
+              </a:lnSpc>
+            </a:pPr>
+            <a:r>
+              <a:rPr sz="750" b="1" i="0">
+                <a:solidFill>
+                  <a:srgbClr val="83E7AE"/>
+                </a:solidFill>
+                <a:latin typeface="Arial"/>
+              </a:rPr>
+              <a:t>MKT STRATEGIC 2 DEPUTY HEAD</a:t>
+            </a:r>
+          </a:p>
+        </p:txBody>
+      </p:sp>
+      <p:cxnSp>
+        <p:nvCxnSpPr>
+          <p:cNvPr id="41" name="Connector 40"/>
+          <p:cNvCxnSpPr/>
+          <p:nvPr/>
+        </p:nvCxnSpPr>
+        <p:spPr>
+          <a:xfrm>
+            <a:off x="3492500" y="3009900"/>
+            <a:ext cx="0" cy="2457450"/>
+          </a:xfrm>
+          <a:prstGeom prst="line">
+            <a:avLst/>
+          </a:prstGeom>
+          <a:ln w="19050">
+            <a:solidFill>
+              <a:srgbClr val="4D555C"/>
+            </a:solidFill>
+          </a:ln>
+        </p:spPr>
+      </p:cxnSp>
+      <p:cxnSp>
+        <p:nvCxnSpPr>
+          <p:cNvPr id="42" name="Connector 41"/>
+          <p:cNvCxnSpPr/>
+          <p:nvPr/>
+        </p:nvCxnSpPr>
+        <p:spPr>
+          <a:xfrm>
+            <a:off x="3492500" y="3333750"/>
+            <a:ext cx="76200" cy="0"/>
+          </a:xfrm>
+          <a:prstGeom prst="line">
+            <a:avLst/>
+          </a:prstGeom>
+          <a:ln w="19050">
+            <a:solidFill>
+              <a:srgbClr val="4D555C"/>
+            </a:solidFill>
+          </a:ln>
+        </p:spPr>
+      </p:cxnSp>
+      <p:sp>
+        <p:nvSpPr>
           <p:cNvPr id="43" name="Rounded Rectangle 42"/>
           <p:cNvSpPr/>
           <p:nvPr/>
         </p:nvSpPr>
         <p:spPr>
           <a:xfrm>
-            <a:off x="2962275" y="3581400"/>
-            <a:ext cx="1924050" cy="438150"/>
+            <a:off x="3568700" y="3105150"/>
+            <a:ext cx="2362200" cy="457200"/>
           </a:xfrm>
           <a:prstGeom prst="roundRect">
             <a:avLst>
-              <a:gd name="adj" fmla="val 10869"/>
+              <a:gd name="adj" fmla="val 10416"/>
             </a:avLst>
           </a:prstGeom>
           <a:solidFill>
@@ -4363,8 +4363,8 @@
         </p:nvSpPr>
         <p:spPr>
           <a:xfrm>
-            <a:off x="3019425" y="3629025"/>
-            <a:ext cx="1809750" cy="152400"/>
+            <a:off x="3625850" y="3152775"/>
+            <a:ext cx="2247900" cy="152400"/>
           </a:xfrm>
           <a:prstGeom prst="rect">
             <a:avLst/>
@@ -4398,8 +4398,8 @@
         </p:nvSpPr>
         <p:spPr>
           <a:xfrm>
-            <a:off x="3019425" y="3781425"/>
-            <a:ext cx="1809750" cy="228600"/>
+            <a:off x="3625850" y="3305175"/>
+            <a:ext cx="2247900" cy="247650"/>
           </a:xfrm>
           <a:prstGeom prst="rect">
             <a:avLst/>
@@ -4437,7 +4437,7 @@
         </p:nvCxnSpPr>
         <p:spPr>
           <a:xfrm>
-            <a:off x="2886075" y="4295775"/>
+            <a:off x="3492500" y="3867150"/>
             <a:ext cx="76200" cy="0"/>
           </a:xfrm>
           <a:prstGeom prst="line">
@@ -4458,12 +4458,12 @@
         </p:nvSpPr>
         <p:spPr>
           <a:xfrm>
-            <a:off x="2962275" y="4076700"/>
-            <a:ext cx="1924050" cy="438150"/>
+            <a:off x="3568700" y="3638550"/>
+            <a:ext cx="2362200" cy="457200"/>
           </a:xfrm>
           <a:prstGeom prst="roundRect">
             <a:avLst>
-              <a:gd name="adj" fmla="val 10869"/>
+              <a:gd name="adj" fmla="val 10416"/>
             </a:avLst>
           </a:prstGeom>
           <a:solidFill>
@@ -4489,8 +4489,8 @@
         </p:nvSpPr>
         <p:spPr>
           <a:xfrm>
-            <a:off x="3019425" y="4124325"/>
-            <a:ext cx="1809750" cy="152400"/>
+            <a:off x="3625850" y="3686175"/>
+            <a:ext cx="2247900" cy="152400"/>
           </a:xfrm>
           <a:prstGeom prst="rect">
             <a:avLst/>
@@ -4524,8 +4524,8 @@
         </p:nvSpPr>
         <p:spPr>
           <a:xfrm>
-            <a:off x="3019425" y="4276725"/>
-            <a:ext cx="1809750" cy="228600"/>
+            <a:off x="3625850" y="3838575"/>
+            <a:ext cx="2247900" cy="247650"/>
           </a:xfrm>
           <a:prstGeom prst="rect">
             <a:avLst/>
@@ -4563,7 +4563,7 @@
         </p:nvCxnSpPr>
         <p:spPr>
           <a:xfrm>
-            <a:off x="2886075" y="4791075"/>
+            <a:off x="3492500" y="4400550"/>
             <a:ext cx="76200" cy="0"/>
           </a:xfrm>
           <a:prstGeom prst="line">
@@ -4584,12 +4584,12 @@
         </p:nvSpPr>
         <p:spPr>
           <a:xfrm>
-            <a:off x="2962275" y="4572000"/>
-            <a:ext cx="1924050" cy="438150"/>
+            <a:off x="3568700" y="4171950"/>
+            <a:ext cx="2362200" cy="457200"/>
           </a:xfrm>
           <a:prstGeom prst="roundRect">
             <a:avLst>
-              <a:gd name="adj" fmla="val 10869"/>
+              <a:gd name="adj" fmla="val 10416"/>
             </a:avLst>
           </a:prstGeom>
           <a:solidFill>
@@ -4615,8 +4615,8 @@
         </p:nvSpPr>
         <p:spPr>
           <a:xfrm>
-            <a:off x="3019425" y="4619625"/>
-            <a:ext cx="1809750" cy="152400"/>
+            <a:off x="3625850" y="4219575"/>
+            <a:ext cx="2247900" cy="152400"/>
           </a:xfrm>
           <a:prstGeom prst="rect">
             <a:avLst/>
@@ -4650,8 +4650,8 @@
         </p:nvSpPr>
         <p:spPr>
           <a:xfrm>
-            <a:off x="3019425" y="4772025"/>
-            <a:ext cx="1809750" cy="228600"/>
+            <a:off x="3625850" y="4371975"/>
+            <a:ext cx="2247900" cy="247650"/>
           </a:xfrm>
           <a:prstGeom prst="rect">
             <a:avLst/>
@@ -4689,7 +4689,7 @@
         </p:nvCxnSpPr>
         <p:spPr>
           <a:xfrm>
-            <a:off x="2886075" y="5286375"/>
+            <a:off x="3492500" y="4933950"/>
             <a:ext cx="76200" cy="0"/>
           </a:xfrm>
           <a:prstGeom prst="line">
@@ -4710,12 +4710,12 @@
         </p:nvSpPr>
         <p:spPr>
           <a:xfrm>
-            <a:off x="2962275" y="5067300"/>
-            <a:ext cx="1924050" cy="438150"/>
+            <a:off x="3568700" y="4705350"/>
+            <a:ext cx="2362200" cy="457200"/>
           </a:xfrm>
           <a:prstGeom prst="roundRect">
             <a:avLst>
-              <a:gd name="adj" fmla="val 10869"/>
+              <a:gd name="adj" fmla="val 10416"/>
             </a:avLst>
           </a:prstGeom>
           <a:solidFill>
@@ -4741,8 +4741,8 @@
         </p:nvSpPr>
         <p:spPr>
           <a:xfrm>
-            <a:off x="3019425" y="5114925"/>
-            <a:ext cx="1809750" cy="152400"/>
+            <a:off x="3625850" y="4752975"/>
+            <a:ext cx="2247900" cy="152400"/>
           </a:xfrm>
           <a:prstGeom prst="rect">
             <a:avLst/>
@@ -4776,8 +4776,8 @@
         </p:nvSpPr>
         <p:spPr>
           <a:xfrm>
-            <a:off x="3019425" y="5267325"/>
-            <a:ext cx="1809750" cy="228600"/>
+            <a:off x="3625850" y="4905375"/>
+            <a:ext cx="2247900" cy="247650"/>
           </a:xfrm>
           <a:prstGeom prst="rect">
             <a:avLst/>
@@ -4815,7 +4815,7 @@
         </p:nvCxnSpPr>
         <p:spPr>
           <a:xfrm>
-            <a:off x="2886075" y="5781675"/>
+            <a:off x="3492500" y="5467350"/>
             <a:ext cx="76200" cy="0"/>
           </a:xfrm>
           <a:prstGeom prst="line">
@@ -4836,12 +4836,12 @@
         </p:nvSpPr>
         <p:spPr>
           <a:xfrm>
-            <a:off x="2962275" y="5562600"/>
-            <a:ext cx="1924050" cy="438150"/>
+            <a:off x="3568700" y="5238750"/>
+            <a:ext cx="2362200" cy="457200"/>
           </a:xfrm>
           <a:prstGeom prst="roundRect">
             <a:avLst>
-              <a:gd name="adj" fmla="val 10869"/>
+              <a:gd name="adj" fmla="val 10416"/>
             </a:avLst>
           </a:prstGeom>
           <a:solidFill>
@@ -4867,8 +4867,8 @@
         </p:nvSpPr>
         <p:spPr>
           <a:xfrm>
-            <a:off x="3019425" y="5610225"/>
-            <a:ext cx="1809750" cy="152400"/>
+            <a:off x="3625850" y="5286375"/>
+            <a:ext cx="2247900" cy="152400"/>
           </a:xfrm>
           <a:prstGeom prst="rect">
             <a:avLst/>
@@ -4902,8 +4902,8 @@
         </p:nvSpPr>
         <p:spPr>
           <a:xfrm>
-            <a:off x="3019425" y="5762625"/>
-            <a:ext cx="1809750" cy="228600"/>
+            <a:off x="3625850" y="5438775"/>
+            <a:ext cx="2247900" cy="247650"/>
           </a:xfrm>
           <a:prstGeom prst="rect">
             <a:avLst/>
@@ -4941,7 +4941,7 @@
         </p:nvCxnSpPr>
         <p:spPr>
           <a:xfrm>
-            <a:off x="6096000" y="2438400"/>
+            <a:off x="7527925" y="2438400"/>
             <a:ext cx="0" cy="152400"/>
           </a:xfrm>
           <a:prstGeom prst="line">
@@ -4962,12 +4962,12 @@
         </p:nvSpPr>
         <p:spPr>
           <a:xfrm>
-            <a:off x="5048250" y="2590800"/>
-            <a:ext cx="2095500" cy="400050"/>
+            <a:off x="6261100" y="2590800"/>
+            <a:ext cx="2533650" cy="419100"/>
           </a:xfrm>
           <a:prstGeom prst="roundRect">
             <a:avLst>
-              <a:gd name="adj" fmla="val 11904"/>
+              <a:gd name="adj" fmla="val 11363"/>
             </a:avLst>
           </a:prstGeom>
           <a:solidFill>
@@ -4991,8 +4991,8 @@
         </p:nvSpPr>
         <p:spPr>
           <a:xfrm>
-            <a:off x="5105400" y="2638425"/>
-            <a:ext cx="1981200" cy="152400"/>
+            <a:off x="6318250" y="2638425"/>
+            <a:ext cx="2419350" cy="152400"/>
           </a:xfrm>
           <a:prstGeom prst="rect">
             <a:avLst/>
@@ -5026,8 +5026,8 @@
         </p:nvSpPr>
         <p:spPr>
           <a:xfrm>
-            <a:off x="5105400" y="2790825"/>
-            <a:ext cx="1981200" cy="190500"/>
+            <a:off x="6318250" y="2790825"/>
+            <a:ext cx="2419350" cy="209550"/>
           </a:xfrm>
           <a:prstGeom prst="rect">
             <a:avLst/>
@@ -5065,8 +5065,8 @@
         </p:nvCxnSpPr>
         <p:spPr>
           <a:xfrm>
-            <a:off x="5143500" y="2990850"/>
-            <a:ext cx="0" cy="1933575"/>
+            <a:off x="6356350" y="3009900"/>
+            <a:ext cx="0" cy="1924050"/>
           </a:xfrm>
           <a:prstGeom prst="line">
             <a:avLst/>
@@ -5086,7 +5086,7 @@
         </p:nvCxnSpPr>
         <p:spPr>
           <a:xfrm>
-            <a:off x="5143500" y="3324225"/>
+            <a:off x="6356350" y="3333750"/>
             <a:ext cx="76200" cy="0"/>
           </a:xfrm>
           <a:prstGeom prst="line">
@@ -5107,12 +5107,12 @@
         </p:nvSpPr>
         <p:spPr>
           <a:xfrm>
-            <a:off x="5219700" y="3086100"/>
-            <a:ext cx="1924050" cy="476250"/>
+            <a:off x="6432550" y="3105150"/>
+            <a:ext cx="2362200" cy="457200"/>
           </a:xfrm>
           <a:prstGeom prst="roundRect">
             <a:avLst>
-              <a:gd name="adj" fmla="val 10000"/>
+              <a:gd name="adj" fmla="val 10416"/>
             </a:avLst>
           </a:prstGeom>
           <a:solidFill>
@@ -5138,8 +5138,8 @@
         </p:nvSpPr>
         <p:spPr>
           <a:xfrm>
-            <a:off x="5276850" y="3133725"/>
-            <a:ext cx="1809750" cy="152400"/>
+            <a:off x="6489700" y="3152775"/>
+            <a:ext cx="2247900" cy="152400"/>
           </a:xfrm>
           <a:prstGeom prst="rect">
             <a:avLst/>
@@ -5173,8 +5173,8 @@
         </p:nvSpPr>
         <p:spPr>
           <a:xfrm>
-            <a:off x="5276850" y="3286125"/>
-            <a:ext cx="1809750" cy="266700"/>
+            <a:off x="6489700" y="3305175"/>
+            <a:ext cx="2247900" cy="247650"/>
           </a:xfrm>
           <a:prstGeom prst="rect">
             <a:avLst/>
@@ -5212,7 +5212,7 @@
         </p:nvCxnSpPr>
         <p:spPr>
           <a:xfrm>
-            <a:off x="5143500" y="3857625"/>
+            <a:off x="6356350" y="3867150"/>
             <a:ext cx="76200" cy="0"/>
           </a:xfrm>
           <a:prstGeom prst="line">
@@ -5233,12 +5233,12 @@
         </p:nvSpPr>
         <p:spPr>
           <a:xfrm>
-            <a:off x="5219700" y="3619500"/>
-            <a:ext cx="1924050" cy="476250"/>
+            <a:off x="6432550" y="3638550"/>
+            <a:ext cx="2362200" cy="457200"/>
           </a:xfrm>
           <a:prstGeom prst="roundRect">
             <a:avLst>
-              <a:gd name="adj" fmla="val 10000"/>
+              <a:gd name="adj" fmla="val 10416"/>
             </a:avLst>
           </a:prstGeom>
           <a:solidFill>
@@ -5264,8 +5264,8 @@
         </p:nvSpPr>
         <p:spPr>
           <a:xfrm>
-            <a:off x="5276850" y="3667125"/>
-            <a:ext cx="1809750" cy="152400"/>
+            <a:off x="6489700" y="3686175"/>
+            <a:ext cx="2247900" cy="152400"/>
           </a:xfrm>
           <a:prstGeom prst="rect">
             <a:avLst/>
@@ -5299,8 +5299,8 @@
         </p:nvSpPr>
         <p:spPr>
           <a:xfrm>
-            <a:off x="5276850" y="3819525"/>
-            <a:ext cx="1809750" cy="266700"/>
+            <a:off x="6489700" y="3838575"/>
+            <a:ext cx="2247900" cy="247650"/>
           </a:xfrm>
           <a:prstGeom prst="rect">
             <a:avLst/>
@@ -5338,7 +5338,7 @@
         </p:nvCxnSpPr>
         <p:spPr>
           <a:xfrm>
-            <a:off x="5143500" y="4391025"/>
+            <a:off x="6356350" y="4400550"/>
             <a:ext cx="76200" cy="0"/>
           </a:xfrm>
           <a:prstGeom prst="line">
@@ -5359,12 +5359,12 @@
         </p:nvSpPr>
         <p:spPr>
           <a:xfrm>
-            <a:off x="5219700" y="4152900"/>
-            <a:ext cx="1924050" cy="476250"/>
+            <a:off x="6432550" y="4171950"/>
+            <a:ext cx="2362200" cy="457200"/>
           </a:xfrm>
           <a:prstGeom prst="roundRect">
             <a:avLst>
-              <a:gd name="adj" fmla="val 10000"/>
+              <a:gd name="adj" fmla="val 10416"/>
             </a:avLst>
           </a:prstGeom>
           <a:solidFill>
@@ -5390,8 +5390,8 @@
         </p:nvSpPr>
         <p:spPr>
           <a:xfrm>
-            <a:off x="5276850" y="4200525"/>
-            <a:ext cx="1809750" cy="152400"/>
+            <a:off x="6489700" y="4219575"/>
+            <a:ext cx="2247900" cy="152400"/>
           </a:xfrm>
           <a:prstGeom prst="rect">
             <a:avLst/>
@@ -5425,8 +5425,8 @@
         </p:nvSpPr>
         <p:spPr>
           <a:xfrm>
-            <a:off x="5276850" y="4352925"/>
-            <a:ext cx="1809750" cy="266700"/>
+            <a:off x="6489700" y="4371975"/>
+            <a:ext cx="2247900" cy="247650"/>
           </a:xfrm>
           <a:prstGeom prst="rect">
             <a:avLst/>
@@ -5464,7 +5464,7 @@
         </p:nvCxnSpPr>
         <p:spPr>
           <a:xfrm>
-            <a:off x="5143500" y="4924425"/>
+            <a:off x="6356350" y="4933950"/>
             <a:ext cx="76200" cy="0"/>
           </a:xfrm>
           <a:prstGeom prst="line">
@@ -5485,12 +5485,12 @@
         </p:nvSpPr>
         <p:spPr>
           <a:xfrm>
-            <a:off x="5219700" y="4686300"/>
-            <a:ext cx="1924050" cy="476250"/>
+            <a:off x="6432550" y="4705350"/>
+            <a:ext cx="2362200" cy="457200"/>
           </a:xfrm>
           <a:prstGeom prst="roundRect">
             <a:avLst>
-              <a:gd name="adj" fmla="val 10000"/>
+              <a:gd name="adj" fmla="val 10416"/>
             </a:avLst>
           </a:prstGeom>
           <a:solidFill>
@@ -5516,8 +5516,8 @@
         </p:nvSpPr>
         <p:spPr>
           <a:xfrm>
-            <a:off x="5276850" y="4733925"/>
-            <a:ext cx="1809750" cy="152400"/>
+            <a:off x="6489700" y="4752975"/>
+            <a:ext cx="2247900" cy="152400"/>
           </a:xfrm>
           <a:prstGeom prst="rect">
             <a:avLst/>
@@ -5551,8 +5551,8 @@
         </p:nvSpPr>
         <p:spPr>
           <a:xfrm>
-            <a:off x="5276850" y="4886325"/>
-            <a:ext cx="1809750" cy="266700"/>
+            <a:off x="6489700" y="4905375"/>
+            <a:ext cx="2247900" cy="247650"/>
           </a:xfrm>
           <a:prstGeom prst="rect">
             <a:avLst/>
@@ -5590,7 +5590,7 @@
         </p:nvCxnSpPr>
         <p:spPr>
           <a:xfrm>
-            <a:off x="8353425" y="2438400"/>
+            <a:off x="10391775" y="2438400"/>
             <a:ext cx="0" cy="152400"/>
           </a:xfrm>
           <a:prstGeom prst="line">
@@ -5611,12 +5611,12 @@
         </p:nvSpPr>
         <p:spPr>
           <a:xfrm>
-            <a:off x="7305675" y="2590800"/>
-            <a:ext cx="2095500" cy="400050"/>
+            <a:off x="9124950" y="2590800"/>
+            <a:ext cx="2533650" cy="419100"/>
           </a:xfrm>
           <a:prstGeom prst="roundRect">
             <a:avLst>
-              <a:gd name="adj" fmla="val 11904"/>
+              <a:gd name="adj" fmla="val 11363"/>
             </a:avLst>
           </a:prstGeom>
           <a:solidFill>
@@ -5640,8 +5640,8 @@
         </p:nvSpPr>
         <p:spPr>
           <a:xfrm>
-            <a:off x="7362825" y="2638425"/>
-            <a:ext cx="1981200" cy="152400"/>
+            <a:off x="9182100" y="2638425"/>
+            <a:ext cx="2419350" cy="152400"/>
           </a:xfrm>
           <a:prstGeom prst="rect">
             <a:avLst/>
@@ -5675,8 +5675,8 @@
         </p:nvSpPr>
         <p:spPr>
           <a:xfrm>
-            <a:off x="7362825" y="2790825"/>
-            <a:ext cx="1981200" cy="190500"/>
+            <a:off x="9182100" y="2790825"/>
+            <a:ext cx="2419350" cy="209550"/>
           </a:xfrm>
           <a:prstGeom prst="rect">
             <a:avLst/>
@@ -5714,8 +5714,8 @@
         </p:nvCxnSpPr>
         <p:spPr>
           <a:xfrm>
-            <a:off x="7400925" y="2990850"/>
-            <a:ext cx="0" cy="1933575"/>
+            <a:off x="9220200" y="3009900"/>
+            <a:ext cx="0" cy="1924050"/>
           </a:xfrm>
           <a:prstGeom prst="line">
             <a:avLst/>
@@ -5735,7 +5735,7 @@
         </p:nvCxnSpPr>
         <p:spPr>
           <a:xfrm>
-            <a:off x="7400925" y="3324225"/>
+            <a:off x="9220200" y="3333750"/>
             <a:ext cx="76200" cy="0"/>
           </a:xfrm>
           <a:prstGeom prst="line">
@@ -5756,12 +5756,12 @@
         </p:nvSpPr>
         <p:spPr>
           <a:xfrm>
-            <a:off x="7477125" y="3086100"/>
-            <a:ext cx="1924050" cy="476250"/>
+            <a:off x="9296400" y="3105150"/>
+            <a:ext cx="2362200" cy="457200"/>
           </a:xfrm>
           <a:prstGeom prst="roundRect">
             <a:avLst>
-              <a:gd name="adj" fmla="val 10000"/>
+              <a:gd name="adj" fmla="val 10416"/>
             </a:avLst>
           </a:prstGeom>
           <a:solidFill>
@@ -5787,8 +5787,8 @@
         </p:nvSpPr>
         <p:spPr>
           <a:xfrm>
-            <a:off x="7534275" y="3133725"/>
-            <a:ext cx="1809750" cy="152400"/>
+            <a:off x="9353550" y="3152775"/>
+            <a:ext cx="2247900" cy="152400"/>
           </a:xfrm>
           <a:prstGeom prst="rect">
             <a:avLst/>
@@ -5822,8 +5822,8 @@
         </p:nvSpPr>
         <p:spPr>
           <a:xfrm>
-            <a:off x="7534275" y="3286125"/>
-            <a:ext cx="1809750" cy="266700"/>
+            <a:off x="9353550" y="3305175"/>
+            <a:ext cx="2247900" cy="247650"/>
           </a:xfrm>
           <a:prstGeom prst="rect">
             <a:avLst/>
@@ -5861,7 +5861,7 @@
         </p:nvCxnSpPr>
         <p:spPr>
           <a:xfrm>
-            <a:off x="7400925" y="3857625"/>
+            <a:off x="9220200" y="3867150"/>
             <a:ext cx="76200" cy="0"/>
           </a:xfrm>
           <a:prstGeom prst="line">
@@ -5882,12 +5882,12 @@
         </p:nvSpPr>
         <p:spPr>
           <a:xfrm>
-            <a:off x="7477125" y="3619500"/>
-            <a:ext cx="1924050" cy="476250"/>
+            <a:off x="9296400" y="3638550"/>
+            <a:ext cx="2362200" cy="457200"/>
           </a:xfrm>
           <a:prstGeom prst="roundRect">
             <a:avLst>
-              <a:gd name="adj" fmla="val 10000"/>
+              <a:gd name="adj" fmla="val 10416"/>
             </a:avLst>
           </a:prstGeom>
           <a:solidFill>
@@ -5913,8 +5913,8 @@
         </p:nvSpPr>
         <p:spPr>
           <a:xfrm>
-            <a:off x="7534275" y="3667125"/>
-            <a:ext cx="1809750" cy="152400"/>
+            <a:off x="9353550" y="3686175"/>
+            <a:ext cx="2247900" cy="152400"/>
           </a:xfrm>
           <a:prstGeom prst="rect">
             <a:avLst/>
@@ -5948,8 +5948,8 @@
         </p:nvSpPr>
         <p:spPr>
           <a:xfrm>
-            <a:off x="7534275" y="3819525"/>
-            <a:ext cx="1809750" cy="266700"/>
+            <a:off x="9353550" y="3838575"/>
+            <a:ext cx="2247900" cy="247650"/>
           </a:xfrm>
           <a:prstGeom prst="rect">
             <a:avLst/>
@@ -5987,7 +5987,7 @@
         </p:nvCxnSpPr>
         <p:spPr>
           <a:xfrm>
-            <a:off x="7400925" y="4391025"/>
+            <a:off x="9220200" y="4400550"/>
             <a:ext cx="76200" cy="0"/>
           </a:xfrm>
           <a:prstGeom prst="line">
@@ -6008,12 +6008,12 @@
         </p:nvSpPr>
         <p:spPr>
           <a:xfrm>
-            <a:off x="7477125" y="4152900"/>
-            <a:ext cx="1924050" cy="476250"/>
+            <a:off x="9296400" y="4171950"/>
+            <a:ext cx="2362200" cy="457200"/>
           </a:xfrm>
           <a:prstGeom prst="roundRect">
             <a:avLst>
-              <a:gd name="adj" fmla="val 10000"/>
+              <a:gd name="adj" fmla="val 10416"/>
             </a:avLst>
           </a:prstGeom>
           <a:solidFill>
@@ -6039,8 +6039,8 @@
         </p:nvSpPr>
         <p:spPr>
           <a:xfrm>
-            <a:off x="7534275" y="4200525"/>
-            <a:ext cx="1809750" cy="152400"/>
+            <a:off x="9353550" y="4219575"/>
+            <a:ext cx="2247900" cy="152400"/>
           </a:xfrm>
           <a:prstGeom prst="rect">
             <a:avLst/>
@@ -6074,8 +6074,8 @@
         </p:nvSpPr>
         <p:spPr>
           <a:xfrm>
-            <a:off x="7534275" y="4352925"/>
-            <a:ext cx="1809750" cy="266700"/>
+            <a:off x="9353550" y="4371975"/>
+            <a:ext cx="2247900" cy="247650"/>
           </a:xfrm>
           <a:prstGeom prst="rect">
             <a:avLst/>
@@ -6113,7 +6113,7 @@
         </p:nvCxnSpPr>
         <p:spPr>
           <a:xfrm>
-            <a:off x="7400925" y="4924425"/>
+            <a:off x="9220200" y="4933950"/>
             <a:ext cx="76200" cy="0"/>
           </a:xfrm>
           <a:prstGeom prst="line">
@@ -6134,12 +6134,12 @@
         </p:nvSpPr>
         <p:spPr>
           <a:xfrm>
-            <a:off x="7477125" y="4686300"/>
-            <a:ext cx="1924050" cy="476250"/>
+            <a:off x="9296400" y="4705350"/>
+            <a:ext cx="2362200" cy="457200"/>
           </a:xfrm>
           <a:prstGeom prst="roundRect">
             <a:avLst>
-              <a:gd name="adj" fmla="val 10000"/>
+              <a:gd name="adj" fmla="val 10416"/>
             </a:avLst>
           </a:prstGeom>
           <a:solidFill>
@@ -6165,8 +6165,8 @@
         </p:nvSpPr>
         <p:spPr>
           <a:xfrm>
-            <a:off x="7534275" y="4733925"/>
-            <a:ext cx="1809750" cy="152400"/>
+            <a:off x="9353550" y="4752975"/>
+            <a:ext cx="2247900" cy="152400"/>
           </a:xfrm>
           <a:prstGeom prst="rect">
             <a:avLst/>
@@ -6200,8 +6200,8 @@
         </p:nvSpPr>
         <p:spPr>
           <a:xfrm>
-            <a:off x="7534275" y="4886325"/>
-            <a:ext cx="1809750" cy="266700"/>
+            <a:off x="9353550" y="4905375"/>
+            <a:ext cx="2247900" cy="247650"/>
           </a:xfrm>
           <a:prstGeom prst="rect">
             <a:avLst/>
@@ -6227,529 +6227,6 @@
                 <a:latin typeface="Arial"/>
               </a:rPr>
               <a:t>On-road Trailer (FBT, SCT), Medium Vessel, Crusher, Bucket</a:t>
-            </a:r>
-          </a:p>
-        </p:txBody>
-      </p:sp>
-      <p:cxnSp>
-        <p:nvCxnSpPr>
-          <p:cNvPr id="104" name="Connector 103"/>
-          <p:cNvCxnSpPr/>
-          <p:nvPr/>
-        </p:nvCxnSpPr>
-        <p:spPr>
-          <a:xfrm>
-            <a:off x="10610850" y="2438400"/>
-            <a:ext cx="0" cy="152400"/>
-          </a:xfrm>
-          <a:prstGeom prst="line">
-            <a:avLst/>
-          </a:prstGeom>
-          <a:ln w="19050">
-            <a:solidFill>
-              <a:srgbClr val="4D555C"/>
-            </a:solidFill>
-          </a:ln>
-        </p:spPr>
-      </p:cxnSp>
-      <p:sp>
-        <p:nvSpPr>
-          <p:cNvPr id="105" name="Rounded Rectangle 104"/>
-          <p:cNvSpPr/>
-          <p:nvPr/>
-        </p:nvSpPr>
-        <p:spPr>
-          <a:xfrm>
-            <a:off x="9563100" y="2590800"/>
-            <a:ext cx="2095500" cy="400050"/>
-          </a:xfrm>
-          <a:prstGeom prst="roundRect">
-            <a:avLst>
-              <a:gd name="adj" fmla="val 11904"/>
-            </a:avLst>
-          </a:prstGeom>
-          <a:solidFill>
-            <a:srgbClr val="11181C"/>
-          </a:solidFill>
-          <a:ln>
-            <a:noFill/>
-          </a:ln>
-        </p:spPr>
-        <p:txBody>
-          <a:bodyPr rtlCol="0" anchor="ctr"/>
-          <a:lstStyle/>
-          <a:p/>
-        </p:txBody>
-      </p:sp>
-      <p:sp>
-        <p:nvSpPr>
-          <p:cNvPr id="106" name="TextBox 105"/>
-          <p:cNvSpPr txBox="1"/>
-          <p:nvPr/>
-        </p:nvSpPr>
-        <p:spPr>
-          <a:xfrm>
-            <a:off x="9620250" y="2638425"/>
-            <a:ext cx="1981200" cy="152400"/>
-          </a:xfrm>
-          <a:prstGeom prst="rect">
-            <a:avLst/>
-          </a:prstGeom>
-          <a:noFill/>
-        </p:spPr>
-        <p:txBody>
-          <a:bodyPr wrap="square" lIns="0" rIns="0" tIns="0" bIns="0" anchor="t">
-            <a:spAutoFit/>
-          </a:bodyPr>
-          <a:lstStyle/>
-          <a:p>
-            <a:pPr algn="ctr"/>
-            <a:r>
-              <a:rPr sz="1000" b="1" i="0">
-                <a:solidFill>
-                  <a:srgbClr val="FFFFFF"/>
-                </a:solidFill>
-                <a:latin typeface="Arial"/>
-              </a:rPr>
-              <a:t>Marketing Communication</a:t>
-            </a:r>
-          </a:p>
-        </p:txBody>
-      </p:sp>
-      <p:sp>
-        <p:nvSpPr>
-          <p:cNvPr id="107" name="TextBox 106"/>
-          <p:cNvSpPr txBox="1"/>
-          <p:nvPr/>
-        </p:nvSpPr>
-        <p:spPr>
-          <a:xfrm>
-            <a:off x="9620250" y="2790825"/>
-            <a:ext cx="1981200" cy="190500"/>
-          </a:xfrm>
-          <a:prstGeom prst="rect">
-            <a:avLst/>
-          </a:prstGeom>
-          <a:noFill/>
-        </p:spPr>
-        <p:txBody>
-          <a:bodyPr wrap="square" lIns="0" rIns="0" tIns="0" bIns="0" anchor="t">
-            <a:spAutoFit/>
-          </a:bodyPr>
-          <a:lstStyle/>
-          <a:p>
-            <a:pPr algn="ctr">
-              <a:lnSpc>
-                <a:spcPct val="100000"/>
-              </a:lnSpc>
-            </a:pPr>
-            <a:r>
-              <a:rPr sz="750" b="1" i="0">
-                <a:solidFill>
-                  <a:srgbClr val="83E7AE"/>
-                </a:solidFill>
-                <a:latin typeface="Arial"/>
-              </a:rPr>
-              <a:t>MARCOMM</a:t>
-            </a:r>
-          </a:p>
-        </p:txBody>
-      </p:sp>
-      <p:cxnSp>
-        <p:nvCxnSpPr>
-          <p:cNvPr id="108" name="Connector 107"/>
-          <p:cNvCxnSpPr/>
-          <p:nvPr/>
-        </p:nvCxnSpPr>
-        <p:spPr>
-          <a:xfrm>
-            <a:off x="9658350" y="2990850"/>
-            <a:ext cx="0" cy="1400175"/>
-          </a:xfrm>
-          <a:prstGeom prst="line">
-            <a:avLst/>
-          </a:prstGeom>
-          <a:ln w="19050">
-            <a:solidFill>
-              <a:srgbClr val="4D555C"/>
-            </a:solidFill>
-          </a:ln>
-        </p:spPr>
-      </p:cxnSp>
-      <p:cxnSp>
-        <p:nvCxnSpPr>
-          <p:cNvPr id="109" name="Connector 108"/>
-          <p:cNvCxnSpPr/>
-          <p:nvPr/>
-        </p:nvCxnSpPr>
-        <p:spPr>
-          <a:xfrm>
-            <a:off x="9658350" y="3324225"/>
-            <a:ext cx="76200" cy="0"/>
-          </a:xfrm>
-          <a:prstGeom prst="line">
-            <a:avLst/>
-          </a:prstGeom>
-          <a:ln w="19050">
-            <a:solidFill>
-              <a:srgbClr val="4D555C"/>
-            </a:solidFill>
-          </a:ln>
-        </p:spPr>
-      </p:cxnSp>
-      <p:sp>
-        <p:nvSpPr>
-          <p:cNvPr id="110" name="Rounded Rectangle 109"/>
-          <p:cNvSpPr/>
-          <p:nvPr/>
-        </p:nvSpPr>
-        <p:spPr>
-          <a:xfrm>
-            <a:off x="9734550" y="3086100"/>
-            <a:ext cx="1924050" cy="476250"/>
-          </a:xfrm>
-          <a:prstGeom prst="roundRect">
-            <a:avLst>
-              <a:gd name="adj" fmla="val 10000"/>
-            </a:avLst>
-          </a:prstGeom>
-          <a:solidFill>
-            <a:srgbClr val="FFFFFF"/>
-          </a:solidFill>
-          <a:ln w="9525">
-            <a:solidFill>
-              <a:srgbClr val="889096"/>
-            </a:solidFill>
-          </a:ln>
-        </p:spPr>
-        <p:txBody>
-          <a:bodyPr rtlCol="0" anchor="ctr"/>
-          <a:lstStyle/>
-          <a:p/>
-        </p:txBody>
-      </p:sp>
-      <p:sp>
-        <p:nvSpPr>
-          <p:cNvPr id="111" name="TextBox 110"/>
-          <p:cNvSpPr txBox="1"/>
-          <p:nvPr/>
-        </p:nvSpPr>
-        <p:spPr>
-          <a:xfrm>
-            <a:off x="9791700" y="3133725"/>
-            <a:ext cx="1809750" cy="152400"/>
-          </a:xfrm>
-          <a:prstGeom prst="rect">
-            <a:avLst/>
-          </a:prstGeom>
-          <a:noFill/>
-        </p:spPr>
-        <p:txBody>
-          <a:bodyPr wrap="square" lIns="0" rIns="0" tIns="0" bIns="0" anchor="t">
-            <a:spAutoFit/>
-          </a:bodyPr>
-          <a:lstStyle/>
-          <a:p>
-            <a:pPr algn="ctr"/>
-            <a:r>
-              <a:rPr sz="1000" b="1" i="0">
-                <a:solidFill>
-                  <a:srgbClr val="11181C"/>
-                </a:solidFill>
-                <a:latin typeface="Arial"/>
-              </a:rPr>
-              <a:t>Karina Audina E.</a:t>
-            </a:r>
-          </a:p>
-        </p:txBody>
-      </p:sp>
-      <p:sp>
-        <p:nvSpPr>
-          <p:cNvPr id="112" name="TextBox 111"/>
-          <p:cNvSpPr txBox="1"/>
-          <p:nvPr/>
-        </p:nvSpPr>
-        <p:spPr>
-          <a:xfrm>
-            <a:off x="9791700" y="3286125"/>
-            <a:ext cx="1809750" cy="266700"/>
-          </a:xfrm>
-          <a:prstGeom prst="rect">
-            <a:avLst/>
-          </a:prstGeom>
-          <a:noFill/>
-        </p:spPr>
-        <p:txBody>
-          <a:bodyPr wrap="square" lIns="0" rIns="0" tIns="0" bIns="0" anchor="t">
-            <a:spAutoFit/>
-          </a:bodyPr>
-          <a:lstStyle/>
-          <a:p>
-            <a:pPr algn="ctr">
-              <a:lnSpc>
-                <a:spcPct val="100000"/>
-              </a:lnSpc>
-            </a:pPr>
-            <a:r>
-              <a:rPr sz="750" b="0" i="0">
-                <a:solidFill>
-                  <a:srgbClr val="697177"/>
-                </a:solidFill>
-                <a:latin typeface="Arial"/>
-              </a:rPr>
-              <a:t>Marcomm</a:t>
-            </a:r>
-          </a:p>
-        </p:txBody>
-      </p:sp>
-      <p:cxnSp>
-        <p:nvCxnSpPr>
-          <p:cNvPr id="113" name="Connector 112"/>
-          <p:cNvCxnSpPr/>
-          <p:nvPr/>
-        </p:nvCxnSpPr>
-        <p:spPr>
-          <a:xfrm>
-            <a:off x="9658350" y="3857625"/>
-            <a:ext cx="76200" cy="0"/>
-          </a:xfrm>
-          <a:prstGeom prst="line">
-            <a:avLst/>
-          </a:prstGeom>
-          <a:ln w="19050">
-            <a:solidFill>
-              <a:srgbClr val="4D555C"/>
-            </a:solidFill>
-          </a:ln>
-        </p:spPr>
-      </p:cxnSp>
-      <p:sp>
-        <p:nvSpPr>
-          <p:cNvPr id="114" name="Rounded Rectangle 113"/>
-          <p:cNvSpPr/>
-          <p:nvPr/>
-        </p:nvSpPr>
-        <p:spPr>
-          <a:xfrm>
-            <a:off x="9734550" y="3619500"/>
-            <a:ext cx="1924050" cy="476250"/>
-          </a:xfrm>
-          <a:prstGeom prst="roundRect">
-            <a:avLst>
-              <a:gd name="adj" fmla="val 10000"/>
-            </a:avLst>
-          </a:prstGeom>
-          <a:solidFill>
-            <a:srgbClr val="FFFFFF"/>
-          </a:solidFill>
-          <a:ln w="9525">
-            <a:solidFill>
-              <a:srgbClr val="889096"/>
-            </a:solidFill>
-          </a:ln>
-        </p:spPr>
-        <p:txBody>
-          <a:bodyPr rtlCol="0" anchor="ctr"/>
-          <a:lstStyle/>
-          <a:p/>
-        </p:txBody>
-      </p:sp>
-      <p:sp>
-        <p:nvSpPr>
-          <p:cNvPr id="115" name="TextBox 114"/>
-          <p:cNvSpPr txBox="1"/>
-          <p:nvPr/>
-        </p:nvSpPr>
-        <p:spPr>
-          <a:xfrm>
-            <a:off x="9791700" y="3667125"/>
-            <a:ext cx="1809750" cy="152400"/>
-          </a:xfrm>
-          <a:prstGeom prst="rect">
-            <a:avLst/>
-          </a:prstGeom>
-          <a:noFill/>
-        </p:spPr>
-        <p:txBody>
-          <a:bodyPr wrap="square" lIns="0" rIns="0" tIns="0" bIns="0" anchor="t">
-            <a:spAutoFit/>
-          </a:bodyPr>
-          <a:lstStyle/>
-          <a:p>
-            <a:pPr algn="ctr"/>
-            <a:r>
-              <a:rPr sz="1000" b="1" i="0">
-                <a:solidFill>
-                  <a:srgbClr val="11181C"/>
-                </a:solidFill>
-                <a:latin typeface="Arial"/>
-              </a:rPr>
-              <a:t>Adinda Siti K.</a:t>
-            </a:r>
-          </a:p>
-        </p:txBody>
-      </p:sp>
-      <p:sp>
-        <p:nvSpPr>
-          <p:cNvPr id="116" name="TextBox 115"/>
-          <p:cNvSpPr txBox="1"/>
-          <p:nvPr/>
-        </p:nvSpPr>
-        <p:spPr>
-          <a:xfrm>
-            <a:off x="9791700" y="3819525"/>
-            <a:ext cx="1809750" cy="266700"/>
-          </a:xfrm>
-          <a:prstGeom prst="rect">
-            <a:avLst/>
-          </a:prstGeom>
-          <a:noFill/>
-        </p:spPr>
-        <p:txBody>
-          <a:bodyPr wrap="square" lIns="0" rIns="0" tIns="0" bIns="0" anchor="t">
-            <a:spAutoFit/>
-          </a:bodyPr>
-          <a:lstStyle/>
-          <a:p>
-            <a:pPr algn="ctr">
-              <a:lnSpc>
-                <a:spcPct val="100000"/>
-              </a:lnSpc>
-            </a:pPr>
-            <a:r>
-              <a:rPr sz="750" b="0" i="0">
-                <a:solidFill>
-                  <a:srgbClr val="697177"/>
-                </a:solidFill>
-                <a:latin typeface="Arial"/>
-              </a:rPr>
-              <a:t>Marcomm</a:t>
-            </a:r>
-          </a:p>
-        </p:txBody>
-      </p:sp>
-      <p:cxnSp>
-        <p:nvCxnSpPr>
-          <p:cNvPr id="117" name="Connector 116"/>
-          <p:cNvCxnSpPr/>
-          <p:nvPr/>
-        </p:nvCxnSpPr>
-        <p:spPr>
-          <a:xfrm>
-            <a:off x="9658350" y="4391025"/>
-            <a:ext cx="76200" cy="0"/>
-          </a:xfrm>
-          <a:prstGeom prst="line">
-            <a:avLst/>
-          </a:prstGeom>
-          <a:ln w="19050">
-            <a:solidFill>
-              <a:srgbClr val="4D555C"/>
-            </a:solidFill>
-          </a:ln>
-        </p:spPr>
-      </p:cxnSp>
-      <p:sp>
-        <p:nvSpPr>
-          <p:cNvPr id="118" name="Rounded Rectangle 117"/>
-          <p:cNvSpPr/>
-          <p:nvPr/>
-        </p:nvSpPr>
-        <p:spPr>
-          <a:xfrm>
-            <a:off x="9734550" y="4152900"/>
-            <a:ext cx="1924050" cy="476250"/>
-          </a:xfrm>
-          <a:prstGeom prst="roundRect">
-            <a:avLst>
-              <a:gd name="adj" fmla="val 10000"/>
-            </a:avLst>
-          </a:prstGeom>
-          <a:solidFill>
-            <a:srgbClr val="FFFFFF"/>
-          </a:solidFill>
-          <a:ln w="9525">
-            <a:solidFill>
-              <a:srgbClr val="889096"/>
-            </a:solidFill>
-          </a:ln>
-        </p:spPr>
-        <p:txBody>
-          <a:bodyPr rtlCol="0" anchor="ctr"/>
-          <a:lstStyle/>
-          <a:p/>
-        </p:txBody>
-      </p:sp>
-      <p:sp>
-        <p:nvSpPr>
-          <p:cNvPr id="119" name="TextBox 118"/>
-          <p:cNvSpPr txBox="1"/>
-          <p:nvPr/>
-        </p:nvSpPr>
-        <p:spPr>
-          <a:xfrm>
-            <a:off x="9791700" y="4200525"/>
-            <a:ext cx="1809750" cy="152400"/>
-          </a:xfrm>
-          <a:prstGeom prst="rect">
-            <a:avLst/>
-          </a:prstGeom>
-          <a:noFill/>
-        </p:spPr>
-        <p:txBody>
-          <a:bodyPr wrap="square" lIns="0" rIns="0" tIns="0" bIns="0" anchor="t">
-            <a:spAutoFit/>
-          </a:bodyPr>
-          <a:lstStyle/>
-          <a:p>
-            <a:pPr algn="ctr"/>
-            <a:r>
-              <a:rPr sz="1000" b="1" i="0">
-                <a:solidFill>
-                  <a:srgbClr val="11181C"/>
-                </a:solidFill>
-                <a:latin typeface="Arial"/>
-              </a:rPr>
-              <a:t>Rahma</a:t>
-            </a:r>
-          </a:p>
-        </p:txBody>
-      </p:sp>
-      <p:sp>
-        <p:nvSpPr>
-          <p:cNvPr id="120" name="TextBox 119"/>
-          <p:cNvSpPr txBox="1"/>
-          <p:nvPr/>
-        </p:nvSpPr>
-        <p:spPr>
-          <a:xfrm>
-            <a:off x="9791700" y="4352925"/>
-            <a:ext cx="1809750" cy="266700"/>
-          </a:xfrm>
-          <a:prstGeom prst="rect">
-            <a:avLst/>
-          </a:prstGeom>
-          <a:noFill/>
-        </p:spPr>
-        <p:txBody>
-          <a:bodyPr wrap="square" lIns="0" rIns="0" tIns="0" bIns="0" anchor="t">
-            <a:spAutoFit/>
-          </a:bodyPr>
-          <a:lstStyle/>
-          <a:p>
-            <a:pPr algn="ctr">
-              <a:lnSpc>
-                <a:spcPct val="100000"/>
-              </a:lnSpc>
-            </a:pPr>
-            <a:r>
-              <a:rPr sz="750" b="0" i="0">
-                <a:solidFill>
-                  <a:srgbClr val="697177"/>
-                </a:solidFill>
-                <a:latin typeface="Arial"/>
-              </a:rPr>
-              <a:t>Graphic Designer</a:t>
             </a:r>
           </a:p>
         </p:txBody>

</xml_diff>